<commit_message>
docs: update KISS Sorcar lecture presentation
</commit_message>
<xml_diff>
--- a/papers/kisssorcar/KISS_Sorcar_Lecture.pptx
+++ b/papers/kisssorcar/KISS_Sorcar_Lecture.pptx
@@ -5,7 +5,7 @@
     <p:sldMasterId id="2147483648" r:id="rId1"/>
   </p:sldMasterIdLst>
   <p:notesMasterIdLst>
-    <p:notesMasterId r:id="rId49"/>
+    <p:notesMasterId r:id="rId48"/>
   </p:notesMasterIdLst>
   <p:sldIdLst>
     <p:sldId id="256" r:id="rId2"/>
@@ -52,9 +52,8 @@
     <p:sldId id="294" r:id="rId43"/>
     <p:sldId id="295" r:id="rId44"/>
     <p:sldId id="296" r:id="rId45"/>
-    <p:sldId id="297" r:id="rId46"/>
-    <p:sldId id="298" r:id="rId47"/>
-    <p:sldId id="299" r:id="rId48"/>
+    <p:sldId id="298" r:id="rId46"/>
+    <p:sldId id="299" r:id="rId47"/>
   </p:sldIdLst>
   <p:sldSz cx="12192000" cy="6858000"/>
   <p:notesSz cx="6858000" cy="9144000"/>
@@ -254,7 +253,7 @@
           <a:p>
             <a:fld id="{814D199C-B2D4-9243-A663-77494DA580BD}" type="datetimeFigureOut">
               <a:rPr lang="en-US" smtClean="0"/>
-              <a:t>4/29/26</a:t>
+              <a:t>5/5/26</a:t>
             </a:fld>
             <a:endParaRPr lang="en-US"/>
           </a:p>
@@ -784,7 +783,7 @@
           <a:p>
             <a:fld id="{5BCAD085-E8A6-8845-BD4E-CB4CCA059FC4}" type="datetimeFigureOut">
               <a:rPr lang="en-US" smtClean="0"/>
-              <a:t>4/29/26</a:t>
+              <a:t>5/5/26</a:t>
             </a:fld>
             <a:endParaRPr lang="en-US"/>
           </a:p>
@@ -952,7 +951,7 @@
           <a:p>
             <a:fld id="{5BCAD085-E8A6-8845-BD4E-CB4CCA059FC4}" type="datetimeFigureOut">
               <a:rPr lang="en-US" smtClean="0"/>
-              <a:t>4/29/26</a:t>
+              <a:t>5/5/26</a:t>
             </a:fld>
             <a:endParaRPr lang="en-US"/>
           </a:p>
@@ -1130,7 +1129,7 @@
           <a:p>
             <a:fld id="{5BCAD085-E8A6-8845-BD4E-CB4CCA059FC4}" type="datetimeFigureOut">
               <a:rPr lang="en-US" smtClean="0"/>
-              <a:t>4/29/26</a:t>
+              <a:t>5/5/26</a:t>
             </a:fld>
             <a:endParaRPr lang="en-US"/>
           </a:p>
@@ -1298,7 +1297,7 @@
           <a:p>
             <a:fld id="{5BCAD085-E8A6-8845-BD4E-CB4CCA059FC4}" type="datetimeFigureOut">
               <a:rPr lang="en-US" smtClean="0"/>
-              <a:t>4/29/26</a:t>
+              <a:t>5/5/26</a:t>
             </a:fld>
             <a:endParaRPr lang="en-US"/>
           </a:p>
@@ -1543,7 +1542,7 @@
           <a:p>
             <a:fld id="{5BCAD085-E8A6-8845-BD4E-CB4CCA059FC4}" type="datetimeFigureOut">
               <a:rPr lang="en-US" smtClean="0"/>
-              <a:t>4/29/26</a:t>
+              <a:t>5/5/26</a:t>
             </a:fld>
             <a:endParaRPr lang="en-US"/>
           </a:p>
@@ -1828,7 +1827,7 @@
           <a:p>
             <a:fld id="{5BCAD085-E8A6-8845-BD4E-CB4CCA059FC4}" type="datetimeFigureOut">
               <a:rPr lang="en-US" smtClean="0"/>
-              <a:t>4/29/26</a:t>
+              <a:t>5/5/26</a:t>
             </a:fld>
             <a:endParaRPr lang="en-US"/>
           </a:p>
@@ -2247,7 +2246,7 @@
           <a:p>
             <a:fld id="{5BCAD085-E8A6-8845-BD4E-CB4CCA059FC4}" type="datetimeFigureOut">
               <a:rPr lang="en-US" smtClean="0"/>
-              <a:t>4/29/26</a:t>
+              <a:t>5/5/26</a:t>
             </a:fld>
             <a:endParaRPr lang="en-US"/>
           </a:p>
@@ -2364,7 +2363,7 @@
           <a:p>
             <a:fld id="{5BCAD085-E8A6-8845-BD4E-CB4CCA059FC4}" type="datetimeFigureOut">
               <a:rPr lang="en-US" smtClean="0"/>
-              <a:t>4/29/26</a:t>
+              <a:t>5/5/26</a:t>
             </a:fld>
             <a:endParaRPr lang="en-US"/>
           </a:p>
@@ -2459,7 +2458,7 @@
           <a:p>
             <a:fld id="{5BCAD085-E8A6-8845-BD4E-CB4CCA059FC4}" type="datetimeFigureOut">
               <a:rPr lang="en-US" smtClean="0"/>
-              <a:t>4/29/26</a:t>
+              <a:t>5/5/26</a:t>
             </a:fld>
             <a:endParaRPr lang="en-US"/>
           </a:p>
@@ -2734,7 +2733,7 @@
           <a:p>
             <a:fld id="{5BCAD085-E8A6-8845-BD4E-CB4CCA059FC4}" type="datetimeFigureOut">
               <a:rPr lang="en-US" smtClean="0"/>
-              <a:t>4/29/26</a:t>
+              <a:t>5/5/26</a:t>
             </a:fld>
             <a:endParaRPr lang="en-US"/>
           </a:p>
@@ -2986,7 +2985,7 @@
           <a:p>
             <a:fld id="{5BCAD085-E8A6-8845-BD4E-CB4CCA059FC4}" type="datetimeFigureOut">
               <a:rPr lang="en-US" smtClean="0"/>
-              <a:t>4/29/26</a:t>
+              <a:t>5/5/26</a:t>
             </a:fld>
             <a:endParaRPr lang="en-US"/>
           </a:p>
@@ -3197,7 +3196,7 @@
           <a:p>
             <a:fld id="{5BCAD085-E8A6-8845-BD4E-CB4CCA059FC4}" type="datetimeFigureOut">
               <a:rPr lang="en-US" smtClean="0"/>
-              <a:t>4/29/26</a:t>
+              <a:t>5/5/26</a:t>
             </a:fld>
             <a:endParaRPr lang="en-US"/>
           </a:p>
@@ -11100,7 +11099,7 @@
       </p:sp>
       <p:sp>
         <p:nvSpPr>
-          <p:cNvPr id="24" name="Chevron 23"/>
+          <p:cNvPr id="27" name="Chevron 23"/>
           <p:cNvSpPr/>
           <p:nvPr/>
         </p:nvSpPr>
@@ -11144,7 +11143,7 @@
       </p:sp>
       <p:sp>
         <p:nvSpPr>
-          <p:cNvPr id="25" name="TextBox 24"/>
+          <p:cNvPr id="28" name="TextBox 24"/>
           <p:cNvSpPr txBox="1"/>
           <p:nvPr/>
         </p:nvSpPr>
@@ -11179,7 +11178,7 @@
       </p:sp>
       <p:sp>
         <p:nvSpPr>
-          <p:cNvPr id="24" name="Chevron 23"/>
+          <p:cNvPr id="29" name="Chevron 23"/>
           <p:cNvSpPr/>
           <p:nvPr/>
         </p:nvSpPr>
@@ -11223,7 +11222,7 @@
       </p:sp>
       <p:sp>
         <p:nvSpPr>
-          <p:cNvPr id="25" name="TextBox 24"/>
+          <p:cNvPr id="30" name="TextBox 24"/>
           <p:cNvSpPr txBox="1"/>
           <p:nvPr/>
         </p:nvSpPr>
@@ -11258,7 +11257,7 @@
       </p:sp>
       <p:sp>
         <p:nvSpPr>
-          <p:cNvPr id="24" name="Chevron 23"/>
+          <p:cNvPr id="31" name="Chevron 23"/>
           <p:cNvSpPr/>
           <p:nvPr/>
         </p:nvSpPr>
@@ -11302,7 +11301,7 @@
       </p:sp>
       <p:sp>
         <p:nvSpPr>
-          <p:cNvPr id="25" name="TextBox 24"/>
+          <p:cNvPr id="32" name="TextBox 24"/>
           <p:cNvSpPr txBox="1"/>
           <p:nvPr/>
         </p:nvSpPr>
@@ -25983,12 +25982,12 @@
           </a:fontRef>
         </p:style>
         <p:txBody>
-          <a:bodyPr rtlCol="0" anchor="ctr" wrap="square" lIns="164592" rIns="164592" tIns="54864" bIns="54864"/>
+          <a:bodyPr wrap="square" lIns="164592" tIns="54864" rIns="164592" bIns="54864" rtlCol="0" anchor="ctr"/>
           <a:lstStyle/>
           <a:p>
             <a:pPr algn="l"/>
             <a:r>
-              <a:rPr b="1" sz="1800">
+              <a:rPr sz="1800" b="1">
                 <a:solidFill>
                   <a:srgbClr val="1F4E79"/>
                 </a:solidFill>
@@ -26047,12 +26046,12 @@
           </a:fontRef>
         </p:style>
         <p:txBody>
-          <a:bodyPr rtlCol="0" anchor="ctr" wrap="square" lIns="164592" rIns="164592" tIns="54864" bIns="54864"/>
+          <a:bodyPr wrap="square" lIns="164592" tIns="54864" rIns="164592" bIns="54864" rtlCol="0" anchor="ctr"/>
           <a:lstStyle/>
           <a:p>
             <a:pPr algn="l"/>
             <a:r>
-              <a:rPr b="1" sz="1800">
+              <a:rPr sz="1800" b="1">
                 <a:solidFill>
                   <a:srgbClr val="1F4E79"/>
                 </a:solidFill>
@@ -26111,12 +26110,12 @@
           </a:fontRef>
         </p:style>
         <p:txBody>
-          <a:bodyPr rtlCol="0" anchor="ctr" wrap="square" lIns="164592" rIns="164592" tIns="54864" bIns="54864"/>
+          <a:bodyPr wrap="square" lIns="164592" tIns="54864" rIns="164592" bIns="54864" rtlCol="0" anchor="ctr"/>
           <a:lstStyle/>
           <a:p>
             <a:pPr algn="l"/>
             <a:r>
-              <a:rPr b="1" sz="1800">
+              <a:rPr sz="1800" b="1">
                 <a:solidFill>
                   <a:srgbClr val="1F4E79"/>
                 </a:solidFill>
@@ -26175,12 +26174,12 @@
           </a:fontRef>
         </p:style>
         <p:txBody>
-          <a:bodyPr rtlCol="0" anchor="ctr" wrap="square" lIns="164592" rIns="164592" tIns="54864" bIns="54864"/>
+          <a:bodyPr wrap="square" lIns="164592" tIns="54864" rIns="164592" bIns="54864" rtlCol="0" anchor="ctr"/>
           <a:lstStyle/>
           <a:p>
             <a:pPr algn="l"/>
             <a:r>
-              <a:rPr b="1" sz="1800">
+              <a:rPr sz="1800" b="1">
                 <a:solidFill>
                   <a:srgbClr val="1F4E79"/>
                 </a:solidFill>
@@ -26239,12 +26238,12 @@
           </a:fontRef>
         </p:style>
         <p:txBody>
-          <a:bodyPr rtlCol="0" anchor="ctr" wrap="square" lIns="164592" rIns="164592" tIns="54864" bIns="54864"/>
+          <a:bodyPr wrap="square" lIns="164592" tIns="54864" rIns="164592" bIns="54864" rtlCol="0" anchor="ctr"/>
           <a:lstStyle/>
           <a:p>
             <a:pPr algn="l"/>
             <a:r>
-              <a:rPr b="1" sz="1800">
+              <a:rPr sz="1800" b="1">
                 <a:solidFill>
                   <a:srgbClr val="1F4E79"/>
                 </a:solidFill>
@@ -26303,12 +26302,12 @@
           </a:fontRef>
         </p:style>
         <p:txBody>
-          <a:bodyPr rtlCol="0" anchor="ctr" wrap="square" lIns="164592" rIns="164592" tIns="54864" bIns="54864"/>
+          <a:bodyPr wrap="square" lIns="164592" tIns="54864" rIns="164592" bIns="54864" rtlCol="0" anchor="ctr"/>
           <a:lstStyle/>
           <a:p>
             <a:pPr algn="l"/>
             <a:r>
-              <a:rPr b="1" sz="1800">
+              <a:rPr sz="1800" b="1">
                 <a:solidFill>
                   <a:srgbClr val="1F4E79"/>
                 </a:solidFill>
@@ -27761,7 +27760,7 @@
               </a:defRPr>
             </a:pPr>
             <a:r>
-              <a:t>The Golden Age of Experts</a:t>
+              <a:t>An Important Advice — Automated Fraud Detection</a:t>
             </a:r>
           </a:p>
         </p:txBody>
@@ -27774,8 +27773,8 @@
         </p:nvSpPr>
         <p:spPr>
           <a:xfrm>
-            <a:off x="1097280" y="1645920"/>
-            <a:ext cx="10058400" cy="365760"/>
+            <a:off x="731520" y="1188720"/>
+            <a:ext cx="10728655" cy="548640"/>
           </a:xfrm>
           <a:prstGeom prst="rect">
             <a:avLst/>
@@ -27788,15 +27787,15 @@
           </a:bodyPr>
           <a:lstStyle/>
           <a:p>
-            <a:pPr>
+            <a:pPr algn="l">
               <a:defRPr sz="1800">
                 <a:solidFill>
-                  <a:srgbClr val="374151"/>
-                </a:solidFill>
-              </a:defRPr>
-            </a:pPr>
-            <a:r>
-              <a:t>» If you are an expert and know how to use frontier models effectively, you are the King.</a:t>
+                  <a:srgbClr val="6B7280"/>
+                </a:solidFill>
+              </a:defRPr>
+            </a:pPr>
+            <a:r>
+              <a:t>Use KISS Sorcar to identify issues in blogs, papers, and code repositories</a:t>
             </a:r>
           </a:p>
         </p:txBody>
@@ -27809,8 +27808,8 @@
         </p:nvSpPr>
         <p:spPr>
           <a:xfrm>
-            <a:off x="1097280" y="2194560"/>
-            <a:ext cx="10058400" cy="365760"/>
+            <a:off x="1828800" y="1828800"/>
+            <a:ext cx="8534095" cy="274320"/>
           </a:xfrm>
           <a:prstGeom prst="rect">
             <a:avLst/>
@@ -27818,220 +27817,48 @@
           <a:noFill/>
         </p:spPr>
         <p:txBody>
-          <a:bodyPr wrap="square">
+          <a:bodyPr wrap="none">
             <a:spAutoFit/>
           </a:bodyPr>
           <a:lstStyle/>
           <a:p>
             <a:pPr>
-              <a:defRPr sz="1800">
-                <a:solidFill>
-                  <a:srgbClr val="374151"/>
-                </a:solidFill>
-              </a:defRPr>
-            </a:pPr>
-            <a:r>
-              <a:t>» Opus 4.7 is more intelligent than anything we have encountered in the past.</a:t>
-            </a:r>
-          </a:p>
-        </p:txBody>
-      </p:sp>
-      <p:sp>
-        <p:nvSpPr>
-          <p:cNvPr id="8" name="TextBox 7"/>
-          <p:cNvSpPr txBox="1"/>
-          <p:nvPr/>
-        </p:nvSpPr>
-        <p:spPr>
-          <a:xfrm>
-            <a:off x="1097280" y="2743200"/>
-            <a:ext cx="10058400" cy="365760"/>
-          </a:xfrm>
-          <a:prstGeom prst="rect">
-            <a:avLst/>
-          </a:prstGeom>
-          <a:noFill/>
-        </p:spPr>
-        <p:txBody>
-          <a:bodyPr wrap="square">
-            <a:spAutoFit/>
-          </a:bodyPr>
-          <a:lstStyle/>
-          <a:p>
-            <a:pPr>
-              <a:defRPr sz="1800">
-                <a:solidFill>
-                  <a:srgbClr val="374151"/>
-                </a:solidFill>
-              </a:defRPr>
-            </a:pPr>
-            <a:r>
-              <a:t>» We are the bottleneck — exploring what is possible.</a:t>
-            </a:r>
-          </a:p>
-        </p:txBody>
-      </p:sp>
-      <p:sp>
-        <p:nvSpPr>
-          <p:cNvPr id="9" name="TextBox 8"/>
-          <p:cNvSpPr txBox="1"/>
-          <p:nvPr/>
-        </p:nvSpPr>
-        <p:spPr>
-          <a:xfrm>
-            <a:off x="1097280" y="3291840"/>
-            <a:ext cx="10058400" cy="365760"/>
-          </a:xfrm>
-          <a:prstGeom prst="rect">
-            <a:avLst/>
-          </a:prstGeom>
-          <a:noFill/>
-        </p:spPr>
-        <p:txBody>
-          <a:bodyPr wrap="square">
-            <a:spAutoFit/>
-          </a:bodyPr>
-          <a:lstStyle/>
-          <a:p>
-            <a:pPr>
-              <a:defRPr sz="1800">
-                <a:solidFill>
-                  <a:srgbClr val="374151"/>
-                </a:solidFill>
-              </a:defRPr>
-            </a:pPr>
-            <a:r>
-              <a:t>» Several academic research efforts will become obsolete.</a:t>
-            </a:r>
-          </a:p>
-        </p:txBody>
-      </p:sp>
-      <p:sp>
-        <p:nvSpPr>
-          <p:cNvPr id="10" name="TextBox 9"/>
-          <p:cNvSpPr txBox="1"/>
-          <p:nvPr/>
-        </p:nvSpPr>
-        <p:spPr>
-          <a:xfrm>
-            <a:off x="1097280" y="3840480"/>
-            <a:ext cx="10058400" cy="365760"/>
-          </a:xfrm>
-          <a:prstGeom prst="rect">
-            <a:avLst/>
-          </a:prstGeom>
-          <a:noFill/>
-        </p:spPr>
-        <p:txBody>
-          <a:bodyPr wrap="square">
-            <a:spAutoFit/>
-          </a:bodyPr>
-          <a:lstStyle/>
-          <a:p>
-            <a:pPr>
-              <a:defRPr sz="1800">
-                <a:solidFill>
-                  <a:srgbClr val="374151"/>
-                </a:solidFill>
-              </a:defRPr>
-            </a:pPr>
-            <a:r>
-              <a:t>» People will write and customize their own software instead of relying on vendors.</a:t>
-            </a:r>
-          </a:p>
-        </p:txBody>
-      </p:sp>
-      <p:sp>
-        <p:nvSpPr>
-          <p:cNvPr id="11" name="TextBox 10"/>
-          <p:cNvSpPr txBox="1"/>
-          <p:nvPr/>
-        </p:nvSpPr>
-        <p:spPr>
-          <a:xfrm>
-            <a:off x="1097280" y="4389120"/>
-            <a:ext cx="10058400" cy="365760"/>
-          </a:xfrm>
-          <a:prstGeom prst="rect">
-            <a:avLst/>
-          </a:prstGeom>
-          <a:noFill/>
-        </p:spPr>
-        <p:txBody>
-          <a:bodyPr wrap="square">
-            <a:spAutoFit/>
-          </a:bodyPr>
-          <a:lstStyle/>
-          <a:p>
-            <a:pPr>
-              <a:defRPr sz="1800">
-                <a:solidFill>
-                  <a:srgbClr val="374151"/>
-                </a:solidFill>
-              </a:defRPr>
-            </a:pPr>
-            <a:r>
-              <a:t>» We must forget much conventional wisdom to make big strides.</a:t>
-            </a:r>
-          </a:p>
-        </p:txBody>
-      </p:sp>
-      <p:sp>
-        <p:nvSpPr>
-          <p:cNvPr id="12" name="TextBox 11"/>
-          <p:cNvSpPr txBox="1"/>
-          <p:nvPr/>
-        </p:nvSpPr>
-        <p:spPr>
-          <a:xfrm>
-            <a:off x="1097280" y="4937760"/>
-            <a:ext cx="10058400" cy="365760"/>
-          </a:xfrm>
-          <a:prstGeom prst="rect">
-            <a:avLst/>
-          </a:prstGeom>
-          <a:noFill/>
-        </p:spPr>
-        <p:txBody>
-          <a:bodyPr wrap="square">
-            <a:spAutoFit/>
-          </a:bodyPr>
-          <a:lstStyle/>
-          <a:p>
-            <a:pPr>
-              <a:defRPr sz="1800">
-                <a:solidFill>
-                  <a:srgbClr val="374151"/>
-                </a:solidFill>
-              </a:defRPr>
-            </a:pPr>
-            <a:r>
-              <a:t>» In 3–5 years, expert knowledge will be incorporated into the best frontier model.</a:t>
-            </a:r>
-          </a:p>
-        </p:txBody>
-      </p:sp>
-      <p:sp>
-        <p:nvSpPr>
-          <p:cNvPr id="13" name="Rounded Rectangle 12"/>
+              <a:defRPr sz="1100" b="1">
+                <a:solidFill>
+                  <a:srgbClr val="6B7280"/>
+                </a:solidFill>
+                <a:latin typeface="Courier New"/>
+              </a:defRPr>
+            </a:pPr>
+            <a:r>
+              <a:t>FRAUD DETECTION PROMPT</a:t>
+            </a:r>
+          </a:p>
+        </p:txBody>
+      </p:sp>
+      <p:sp>
+        <p:nvSpPr>
+          <p:cNvPr id="8" name="Rounded Rectangle 7"/>
           <p:cNvSpPr/>
           <p:nvPr/>
         </p:nvSpPr>
         <p:spPr>
           <a:xfrm>
-            <a:off x="731520" y="5486400"/>
-            <a:ext cx="10728655" cy="640080"/>
+            <a:off x="1828800" y="2103120"/>
+            <a:ext cx="8534095" cy="3840480"/>
           </a:xfrm>
           <a:prstGeom prst="roundRect">
             <a:avLst>
-              <a:gd name="adj" fmla="val 5000"/>
+              <a:gd name="adj" fmla="val 2000"/>
             </a:avLst>
           </a:prstGeom>
           <a:solidFill>
-            <a:srgbClr val="FFE4E6"/>
+            <a:srgbClr val="F8FAFC"/>
           </a:solidFill>
-          <a:ln>
-            <a:noFill/>
+          <a:ln w="12700">
+            <a:solidFill>
+              <a:srgbClr val="E5E7EB"/>
+            </a:solidFill>
           </a:ln>
         </p:spPr>
         <p:style>
@@ -28049,22 +27876,257 @@
           </a:fontRef>
         </p:style>
         <p:txBody>
-          <a:bodyPr wrap="square" lIns="182880" tIns="137160" rIns="182880" bIns="137160" rtlCol="0" anchor="ctr"/>
-          <a:lstStyle/>
-          <a:p>
-            <a:pPr algn="l">
-              <a:defRPr sz="1500" b="0">
-                <a:solidFill>
-                  <a:srgbClr val="9F1239"/>
-                </a:solidFill>
-              </a:defRPr>
-            </a:pPr>
-            <a:r>
-              <a:t>The biggest problem ahead may not be AI safety — it may be mental health.</a:t>
-            </a:r>
-            <a:br/>
-            <a:r>
-              <a:t>We need to address this before it becomes a crisis.</a:t>
+          <a:bodyPr wrap="square" lIns="228600" tIns="182880" rIns="228600" bIns="182880" rtlCol="0" anchor="ctr"/>
+          <a:lstStyle/>
+          <a:p>
+            <a:pPr>
+              <a:lnSpc>
+                <a:spcPts val="1800"/>
+              </a:lnSpc>
+              <a:defRPr sz="1300">
+                <a:solidFill>
+                  <a:srgbClr val="374151"/>
+                </a:solidFill>
+                <a:latin typeface="Courier New"/>
+              </a:defRPr>
+            </a:pPr>
+            <a:r>
+              <a:rPr dirty="0"/>
+              <a:t>Can you read &lt;&lt;</a:t>
+            </a:r>
+            <a:r>
+              <a:rPr dirty="0" err="1"/>
+              <a:t>url</a:t>
+            </a:r>
+            <a:r>
+              <a:rPr dirty="0"/>
+              <a:t>&gt;&gt;, and thoroughly and precisely</a:t>
+            </a:r>
+          </a:p>
+          <a:p>
+            <a:pPr>
+              <a:lnSpc>
+                <a:spcPts val="1800"/>
+              </a:lnSpc>
+              <a:defRPr sz="1300">
+                <a:solidFill>
+                  <a:srgbClr val="374151"/>
+                </a:solidFill>
+                <a:latin typeface="Courier New"/>
+              </a:defRPr>
+            </a:pPr>
+            <a:r>
+              <a:rPr dirty="0"/>
+              <a:t>check for **wrong assumptions**, **cheating**,</a:t>
+            </a:r>
+          </a:p>
+          <a:p>
+            <a:pPr>
+              <a:lnSpc>
+                <a:spcPts val="1800"/>
+              </a:lnSpc>
+              <a:defRPr sz="1300">
+                <a:solidFill>
+                  <a:srgbClr val="374151"/>
+                </a:solidFill>
+                <a:latin typeface="Courier New"/>
+              </a:defRPr>
+            </a:pPr>
+            <a:r>
+              <a:rPr dirty="0"/>
+              <a:t>**irreproducibility issues**, **fraud**,</a:t>
+            </a:r>
+          </a:p>
+          <a:p>
+            <a:pPr>
+              <a:lnSpc>
+                <a:spcPts val="1800"/>
+              </a:lnSpc>
+              <a:defRPr sz="1300">
+                <a:solidFill>
+                  <a:srgbClr val="374151"/>
+                </a:solidFill>
+                <a:latin typeface="Courier New"/>
+              </a:defRPr>
+            </a:pPr>
+            <a:r>
+              <a:rPr dirty="0"/>
+              <a:t>**potential for cheating in evaluation**</a:t>
+            </a:r>
+          </a:p>
+          <a:p>
+            <a:pPr>
+              <a:lnSpc>
+                <a:spcPts val="1800"/>
+              </a:lnSpc>
+              <a:defRPr sz="1300">
+                <a:solidFill>
+                  <a:srgbClr val="374151"/>
+                </a:solidFill>
+                <a:latin typeface="Courier New"/>
+              </a:defRPr>
+            </a:pPr>
+            <a:r>
+              <a:rPr dirty="0"/>
+              <a:t>and **security vulnerabilities**?</a:t>
+            </a:r>
+          </a:p>
+          <a:p>
+            <a:pPr>
+              <a:lnSpc>
+                <a:spcPts val="1800"/>
+              </a:lnSpc>
+              <a:defRPr sz="1300">
+                <a:solidFill>
+                  <a:srgbClr val="374151"/>
+                </a:solidFill>
+                <a:latin typeface="Courier New"/>
+              </a:defRPr>
+            </a:pPr>
+            <a:endParaRPr dirty="0"/>
+          </a:p>
+          <a:p>
+            <a:pPr>
+              <a:lnSpc>
+                <a:spcPts val="1800"/>
+              </a:lnSpc>
+              <a:defRPr sz="1300">
+                <a:solidFill>
+                  <a:srgbClr val="374151"/>
+                </a:solidFill>
+                <a:latin typeface="Courier New"/>
+              </a:defRPr>
+            </a:pPr>
+            <a:r>
+              <a:rPr dirty="0"/>
+              <a:t>Use internet search extensively and do not believe</a:t>
+            </a:r>
+          </a:p>
+          <a:p>
+            <a:pPr>
+              <a:lnSpc>
+                <a:spcPts val="1800"/>
+              </a:lnSpc>
+              <a:defRPr sz="1300">
+                <a:solidFill>
+                  <a:srgbClr val="374151"/>
+                </a:solidFill>
+                <a:latin typeface="Courier New"/>
+              </a:defRPr>
+            </a:pPr>
+            <a:r>
+              <a:rPr dirty="0"/>
+              <a:t>what people say -- verify them yourself.</a:t>
+            </a:r>
+          </a:p>
+          <a:p>
+            <a:pPr>
+              <a:lnSpc>
+                <a:spcPts val="1800"/>
+              </a:lnSpc>
+              <a:defRPr sz="1300">
+                <a:solidFill>
+                  <a:srgbClr val="374151"/>
+                </a:solidFill>
+                <a:latin typeface="Courier New"/>
+              </a:defRPr>
+            </a:pPr>
+            <a:r>
+              <a:rPr dirty="0"/>
+              <a:t>Do not hesitate to download code and run them to</a:t>
+            </a:r>
+          </a:p>
+          <a:p>
+            <a:pPr>
+              <a:lnSpc>
+                <a:spcPts val="1800"/>
+              </a:lnSpc>
+              <a:defRPr sz="1300">
+                <a:solidFill>
+                  <a:srgbClr val="374151"/>
+                </a:solidFill>
+                <a:latin typeface="Courier New"/>
+              </a:defRPr>
+            </a:pPr>
+            <a:r>
+              <a:rPr dirty="0"/>
+              <a:t>validate results.</a:t>
+            </a:r>
+          </a:p>
+          <a:p>
+            <a:pPr>
+              <a:lnSpc>
+                <a:spcPts val="1800"/>
+              </a:lnSpc>
+              <a:defRPr sz="1300">
+                <a:solidFill>
+                  <a:srgbClr val="374151"/>
+                </a:solidFill>
+                <a:latin typeface="Courier New"/>
+              </a:defRPr>
+            </a:pPr>
+            <a:r>
+              <a:rPr dirty="0"/>
+              <a:t>For security vulnerabilities, create a POC and test it.</a:t>
+            </a:r>
+          </a:p>
+          <a:p>
+            <a:pPr>
+              <a:lnSpc>
+                <a:spcPts val="1800"/>
+              </a:lnSpc>
+              <a:defRPr sz="1300">
+                <a:solidFill>
+                  <a:srgbClr val="374151"/>
+                </a:solidFill>
+                <a:latin typeface="Courier New"/>
+              </a:defRPr>
+            </a:pPr>
+            <a:r>
+              <a:rPr dirty="0"/>
+              <a:t>Generate an html report in PWD/</a:t>
+            </a:r>
+            <a:r>
+              <a:rPr dirty="0" err="1"/>
+              <a:t>sorcar_reported_frauds</a:t>
+            </a:r>
+            <a:r>
+              <a:rPr dirty="0"/>
+              <a:t>/</a:t>
+            </a:r>
+          </a:p>
+          <a:p>
+            <a:pPr>
+              <a:lnSpc>
+                <a:spcPts val="1800"/>
+              </a:lnSpc>
+              <a:defRPr sz="1300">
+                <a:solidFill>
+                  <a:srgbClr val="374151"/>
+                </a:solidFill>
+                <a:latin typeface="Courier New"/>
+              </a:defRPr>
+            </a:pPr>
+            <a:r>
+              <a:rPr dirty="0"/>
+              <a:t>and open in the user's default browser.</a:t>
+            </a:r>
+          </a:p>
+          <a:p>
+            <a:pPr>
+              <a:lnSpc>
+                <a:spcPts val="1800"/>
+              </a:lnSpc>
+              <a:defRPr sz="1300">
+                <a:solidFill>
+                  <a:srgbClr val="374151"/>
+                </a:solidFill>
+                <a:latin typeface="Courier New"/>
+              </a:defRPr>
+            </a:pPr>
+            <a:r>
+              <a:rPr dirty="0"/>
+              <a:t>Thoroughly fact check everything you claim in the report.</a:t>
             </a:r>
           </a:p>
         </p:txBody>
@@ -28078,572 +28140,6 @@
 </file>
 
 <file path=ppt/slides/slide46.xml><?xml version="1.0" encoding="utf-8"?>
-<p:sld xmlns:a="http://schemas.openxmlformats.org/drawingml/2006/main" xmlns:r="http://schemas.openxmlformats.org/officeDocument/2006/relationships" xmlns:p="http://schemas.openxmlformats.org/presentationml/2006/main">
-  <p:cSld>
-    <p:spTree>
-      <p:nvGrpSpPr>
-        <p:cNvPr id="1" name=""/>
-        <p:cNvGrpSpPr/>
-        <p:nvPr/>
-      </p:nvGrpSpPr>
-      <p:grpSpPr>
-        <a:xfrm>
-          <a:off x="0" y="0"/>
-          <a:ext cx="0" cy="0"/>
-          <a:chOff x="0" y="0"/>
-          <a:chExt cx="0" cy="0"/>
-        </a:xfrm>
-      </p:grpSpPr>
-      <p:sp>
-        <p:nvSpPr>
-          <p:cNvPr id="2" name="Rectangle 1"/>
-          <p:cNvSpPr/>
-          <p:nvPr/>
-        </p:nvSpPr>
-        <p:spPr>
-          <a:xfrm>
-            <a:off x="0" y="0"/>
-            <a:ext cx="12191695" cy="6858000"/>
-          </a:xfrm>
-          <a:prstGeom prst="rect">
-            <a:avLst/>
-          </a:prstGeom>
-          <a:solidFill>
-            <a:srgbClr val="FFFFFF"/>
-          </a:solidFill>
-          <a:ln>
-            <a:noFill/>
-          </a:ln>
-        </p:spPr>
-        <p:style>
-          <a:lnRef idx="1">
-            <a:schemeClr val="accent1"/>
-          </a:lnRef>
-          <a:fillRef idx="3">
-            <a:schemeClr val="accent1"/>
-          </a:fillRef>
-          <a:effectRef idx="2">
-            <a:schemeClr val="accent1"/>
-          </a:effectRef>
-          <a:fontRef idx="minor">
-            <a:schemeClr val="lt1"/>
-          </a:fontRef>
-        </p:style>
-        <p:txBody>
-          <a:bodyPr rtlCol="0" anchor="ctr"/>
-          <a:lstStyle/>
-          <a:p>
-            <a:pPr algn="ctr"/>
-            <a:endParaRPr/>
-          </a:p>
-        </p:txBody>
-      </p:sp>
-      <p:sp>
-        <p:nvSpPr>
-          <p:cNvPr id="3" name="Rectangle 2"/>
-          <p:cNvSpPr/>
-          <p:nvPr/>
-        </p:nvSpPr>
-        <p:spPr>
-          <a:xfrm>
-            <a:off x="0" y="0"/>
-            <a:ext cx="12191695" cy="54864"/>
-          </a:xfrm>
-          <a:prstGeom prst="rect">
-            <a:avLst/>
-          </a:prstGeom>
-          <a:solidFill>
-            <a:srgbClr val="1B2A4A"/>
-          </a:solidFill>
-          <a:ln>
-            <a:noFill/>
-          </a:ln>
-        </p:spPr>
-        <p:style>
-          <a:lnRef idx="1">
-            <a:schemeClr val="accent1"/>
-          </a:lnRef>
-          <a:fillRef idx="3">
-            <a:schemeClr val="accent1"/>
-          </a:fillRef>
-          <a:effectRef idx="2">
-            <a:schemeClr val="accent1"/>
-          </a:effectRef>
-          <a:fontRef idx="minor">
-            <a:schemeClr val="lt1"/>
-          </a:fontRef>
-        </p:style>
-        <p:txBody>
-          <a:bodyPr rtlCol="0" anchor="ctr"/>
-          <a:lstStyle/>
-          <a:p>
-            <a:pPr algn="ctr"/>
-            <a:endParaRPr/>
-          </a:p>
-        </p:txBody>
-      </p:sp>
-      <p:sp>
-        <p:nvSpPr>
-          <p:cNvPr id="4" name="Rectangle 3"/>
-          <p:cNvSpPr/>
-          <p:nvPr/>
-        </p:nvSpPr>
-        <p:spPr>
-          <a:xfrm>
-            <a:off x="0" y="6492240"/>
-            <a:ext cx="12191695" cy="365760"/>
-          </a:xfrm>
-          <a:prstGeom prst="rect">
-            <a:avLst/>
-          </a:prstGeom>
-          <a:solidFill>
-            <a:srgbClr val="1B2A4A"/>
-          </a:solidFill>
-          <a:ln>
-            <a:noFill/>
-          </a:ln>
-        </p:spPr>
-        <p:style>
-          <a:lnRef idx="1">
-            <a:schemeClr val="accent1"/>
-          </a:lnRef>
-          <a:fillRef idx="3">
-            <a:schemeClr val="accent1"/>
-          </a:fillRef>
-          <a:effectRef idx="2">
-            <a:schemeClr val="accent1"/>
-          </a:effectRef>
-          <a:fontRef idx="minor">
-            <a:schemeClr val="lt1"/>
-          </a:fontRef>
-        </p:style>
-        <p:txBody>
-          <a:bodyPr wrap="square" rtlCol="0" anchor="ctr"/>
-          <a:lstStyle/>
-          <a:p>
-            <a:pPr algn="ctr">
-              <a:defRPr sz="1000">
-                <a:solidFill>
-                  <a:srgbClr val="FFFFFF"/>
-                </a:solidFill>
-              </a:defRPr>
-            </a:pPr>
-            <a:r>
-              <a:t>KISS Sorcar — Koushik Sen, UC Berkeley</a:t>
-            </a:r>
-          </a:p>
-        </p:txBody>
-      </p:sp>
-      <p:sp>
-        <p:nvSpPr>
-          <p:cNvPr id="5" name="TextBox 4"/>
-          <p:cNvSpPr txBox="1"/>
-          <p:nvPr/>
-        </p:nvSpPr>
-        <p:spPr>
-          <a:xfrm>
-            <a:off x="731520" y="457200"/>
-            <a:ext cx="10728655" cy="731520"/>
-          </a:xfrm>
-          <a:prstGeom prst="rect">
-            <a:avLst/>
-          </a:prstGeom>
-          <a:noFill/>
-        </p:spPr>
-        <p:txBody>
-          <a:bodyPr wrap="square">
-            <a:spAutoFit/>
-          </a:bodyPr>
-          <a:lstStyle/>
-          <a:p>
-            <a:pPr algn="l">
-              <a:defRPr sz="3600" b="1">
-                <a:solidFill>
-                  <a:srgbClr val="1B2A4A"/>
-                </a:solidFill>
-              </a:defRPr>
-            </a:pPr>
-            <a:r>
-              <a:t>An Important Advice — Automated Fraud Detection</a:t>
-            </a:r>
-          </a:p>
-        </p:txBody>
-      </p:sp>
-      <p:sp>
-        <p:nvSpPr>
-          <p:cNvPr id="6" name="TextBox 5"/>
-          <p:cNvSpPr txBox="1"/>
-          <p:nvPr/>
-        </p:nvSpPr>
-        <p:spPr>
-          <a:xfrm>
-            <a:off x="731520" y="1188720"/>
-            <a:ext cx="10728655" cy="548640"/>
-          </a:xfrm>
-          <a:prstGeom prst="rect">
-            <a:avLst/>
-          </a:prstGeom>
-          <a:noFill/>
-        </p:spPr>
-        <p:txBody>
-          <a:bodyPr wrap="square">
-            <a:spAutoFit/>
-          </a:bodyPr>
-          <a:lstStyle/>
-          <a:p>
-            <a:pPr algn="l">
-              <a:defRPr sz="1800">
-                <a:solidFill>
-                  <a:srgbClr val="6B7280"/>
-                </a:solidFill>
-              </a:defRPr>
-            </a:pPr>
-            <a:r>
-              <a:t>Use KISS Sorcar to identify issues in blogs, papers, and code repositories</a:t>
-            </a:r>
-          </a:p>
-        </p:txBody>
-      </p:sp>
-      <p:sp>
-        <p:nvSpPr>
-          <p:cNvPr id="7" name="TextBox 6"/>
-          <p:cNvSpPr txBox="1"/>
-          <p:nvPr/>
-        </p:nvSpPr>
-        <p:spPr>
-          <a:xfrm>
-            <a:off x="1828800" y="1828800"/>
-            <a:ext cx="8534095" cy="274320"/>
-          </a:xfrm>
-          <a:prstGeom prst="rect">
-            <a:avLst/>
-          </a:prstGeom>
-          <a:noFill/>
-        </p:spPr>
-        <p:txBody>
-          <a:bodyPr wrap="none">
-            <a:spAutoFit/>
-          </a:bodyPr>
-          <a:lstStyle/>
-          <a:p>
-            <a:pPr>
-              <a:defRPr sz="1100" b="1">
-                <a:solidFill>
-                  <a:srgbClr val="6B7280"/>
-                </a:solidFill>
-                <a:latin typeface="Courier New"/>
-              </a:defRPr>
-            </a:pPr>
-            <a:r>
-              <a:t>FRAUD DETECTION PROMPT</a:t>
-            </a:r>
-          </a:p>
-        </p:txBody>
-      </p:sp>
-      <p:sp>
-        <p:nvSpPr>
-          <p:cNvPr id="8" name="Rounded Rectangle 7"/>
-          <p:cNvSpPr/>
-          <p:nvPr/>
-        </p:nvSpPr>
-        <p:spPr>
-          <a:xfrm>
-            <a:off x="1828800" y="2103120"/>
-            <a:ext cx="8534095" cy="3840480"/>
-          </a:xfrm>
-          <a:prstGeom prst="roundRect">
-            <a:avLst>
-              <a:gd name="adj" fmla="val 2000"/>
-            </a:avLst>
-          </a:prstGeom>
-          <a:solidFill>
-            <a:srgbClr val="F8FAFC"/>
-          </a:solidFill>
-          <a:ln w="12700">
-            <a:solidFill>
-              <a:srgbClr val="E5E7EB"/>
-            </a:solidFill>
-          </a:ln>
-        </p:spPr>
-        <p:style>
-          <a:lnRef idx="1">
-            <a:schemeClr val="accent1"/>
-          </a:lnRef>
-          <a:fillRef idx="3">
-            <a:schemeClr val="accent1"/>
-          </a:fillRef>
-          <a:effectRef idx="2">
-            <a:schemeClr val="accent1"/>
-          </a:effectRef>
-          <a:fontRef idx="minor">
-            <a:schemeClr val="lt1"/>
-          </a:fontRef>
-        </p:style>
-        <p:txBody>
-          <a:bodyPr wrap="square" lIns="228600" tIns="182880" rIns="228600" bIns="182880" rtlCol="0" anchor="ctr"/>
-          <a:lstStyle/>
-          <a:p>
-            <a:pPr>
-              <a:lnSpc>
-                <a:spcPts val="1800"/>
-              </a:lnSpc>
-              <a:defRPr sz="1300">
-                <a:solidFill>
-                  <a:srgbClr val="374151"/>
-                </a:solidFill>
-                <a:latin typeface="Courier New"/>
-              </a:defRPr>
-            </a:pPr>
-            <a:r>
-              <a:rPr dirty="0"/>
-              <a:t>Can you read &lt;&lt;</a:t>
-            </a:r>
-            <a:r>
-              <a:rPr dirty="0" err="1"/>
-              <a:t>url</a:t>
-            </a:r>
-            <a:r>
-              <a:rPr dirty="0"/>
-              <a:t>&gt;&gt;, and thoroughly and precisely</a:t>
-            </a:r>
-          </a:p>
-          <a:p>
-            <a:pPr>
-              <a:lnSpc>
-                <a:spcPts val="1800"/>
-              </a:lnSpc>
-              <a:defRPr sz="1300">
-                <a:solidFill>
-                  <a:srgbClr val="374151"/>
-                </a:solidFill>
-                <a:latin typeface="Courier New"/>
-              </a:defRPr>
-            </a:pPr>
-            <a:r>
-              <a:rPr dirty="0"/>
-              <a:t>check for **wrong assumptions**, **cheating**,</a:t>
-            </a:r>
-          </a:p>
-          <a:p>
-            <a:pPr>
-              <a:lnSpc>
-                <a:spcPts val="1800"/>
-              </a:lnSpc>
-              <a:defRPr sz="1300">
-                <a:solidFill>
-                  <a:srgbClr val="374151"/>
-                </a:solidFill>
-                <a:latin typeface="Courier New"/>
-              </a:defRPr>
-            </a:pPr>
-            <a:r>
-              <a:rPr dirty="0"/>
-              <a:t>**irreproducibility issues**, **fraud**,</a:t>
-            </a:r>
-          </a:p>
-          <a:p>
-            <a:pPr>
-              <a:lnSpc>
-                <a:spcPts val="1800"/>
-              </a:lnSpc>
-              <a:defRPr sz="1300">
-                <a:solidFill>
-                  <a:srgbClr val="374151"/>
-                </a:solidFill>
-                <a:latin typeface="Courier New"/>
-              </a:defRPr>
-            </a:pPr>
-            <a:r>
-              <a:rPr dirty="0"/>
-              <a:t>**potential for cheating in evaluation**</a:t>
-            </a:r>
-          </a:p>
-          <a:p>
-            <a:pPr>
-              <a:lnSpc>
-                <a:spcPts val="1800"/>
-              </a:lnSpc>
-              <a:defRPr sz="1300">
-                <a:solidFill>
-                  <a:srgbClr val="374151"/>
-                </a:solidFill>
-                <a:latin typeface="Courier New"/>
-              </a:defRPr>
-            </a:pPr>
-            <a:r>
-              <a:rPr dirty="0"/>
-              <a:t>and **security vulnerabilities**?</a:t>
-            </a:r>
-          </a:p>
-          <a:p>
-            <a:pPr>
-              <a:lnSpc>
-                <a:spcPts val="1800"/>
-              </a:lnSpc>
-              <a:defRPr sz="1300">
-                <a:solidFill>
-                  <a:srgbClr val="374151"/>
-                </a:solidFill>
-                <a:latin typeface="Courier New"/>
-              </a:defRPr>
-            </a:pPr>
-            <a:endParaRPr dirty="0"/>
-          </a:p>
-          <a:p>
-            <a:pPr>
-              <a:lnSpc>
-                <a:spcPts val="1800"/>
-              </a:lnSpc>
-              <a:defRPr sz="1300">
-                <a:solidFill>
-                  <a:srgbClr val="374151"/>
-                </a:solidFill>
-                <a:latin typeface="Courier New"/>
-              </a:defRPr>
-            </a:pPr>
-            <a:r>
-              <a:rPr dirty="0"/>
-              <a:t>Use internet search extensively and do not believe</a:t>
-            </a:r>
-          </a:p>
-          <a:p>
-            <a:pPr>
-              <a:lnSpc>
-                <a:spcPts val="1800"/>
-              </a:lnSpc>
-              <a:defRPr sz="1300">
-                <a:solidFill>
-                  <a:srgbClr val="374151"/>
-                </a:solidFill>
-                <a:latin typeface="Courier New"/>
-              </a:defRPr>
-            </a:pPr>
-            <a:r>
-              <a:rPr dirty="0"/>
-              <a:t>what people say -- verify them yourself.</a:t>
-            </a:r>
-          </a:p>
-          <a:p>
-            <a:pPr>
-              <a:lnSpc>
-                <a:spcPts val="1800"/>
-              </a:lnSpc>
-              <a:defRPr sz="1300">
-                <a:solidFill>
-                  <a:srgbClr val="374151"/>
-                </a:solidFill>
-                <a:latin typeface="Courier New"/>
-              </a:defRPr>
-            </a:pPr>
-            <a:r>
-              <a:rPr dirty="0"/>
-              <a:t>Do not hesitate to download code and run them to</a:t>
-            </a:r>
-          </a:p>
-          <a:p>
-            <a:pPr>
-              <a:lnSpc>
-                <a:spcPts val="1800"/>
-              </a:lnSpc>
-              <a:defRPr sz="1300">
-                <a:solidFill>
-                  <a:srgbClr val="374151"/>
-                </a:solidFill>
-                <a:latin typeface="Courier New"/>
-              </a:defRPr>
-            </a:pPr>
-            <a:r>
-              <a:rPr dirty="0"/>
-              <a:t>validate results.</a:t>
-            </a:r>
-          </a:p>
-          <a:p>
-            <a:pPr>
-              <a:lnSpc>
-                <a:spcPts val="1800"/>
-              </a:lnSpc>
-              <a:defRPr sz="1300">
-                <a:solidFill>
-                  <a:srgbClr val="374151"/>
-                </a:solidFill>
-                <a:latin typeface="Courier New"/>
-              </a:defRPr>
-            </a:pPr>
-            <a:r>
-              <a:rPr dirty="0"/>
-              <a:t>For security vulnerabilities, create a POC and test it.</a:t>
-            </a:r>
-          </a:p>
-          <a:p>
-            <a:pPr>
-              <a:lnSpc>
-                <a:spcPts val="1800"/>
-              </a:lnSpc>
-              <a:defRPr sz="1300">
-                <a:solidFill>
-                  <a:srgbClr val="374151"/>
-                </a:solidFill>
-                <a:latin typeface="Courier New"/>
-              </a:defRPr>
-            </a:pPr>
-            <a:r>
-              <a:rPr dirty="0"/>
-              <a:t>Generate an html report in PWD/</a:t>
-            </a:r>
-            <a:r>
-              <a:rPr dirty="0" err="1"/>
-              <a:t>sorcar_reported_frauds</a:t>
-            </a:r>
-            <a:r>
-              <a:rPr dirty="0"/>
-              <a:t>/</a:t>
-            </a:r>
-          </a:p>
-          <a:p>
-            <a:pPr>
-              <a:lnSpc>
-                <a:spcPts val="1800"/>
-              </a:lnSpc>
-              <a:defRPr sz="1300">
-                <a:solidFill>
-                  <a:srgbClr val="374151"/>
-                </a:solidFill>
-                <a:latin typeface="Courier New"/>
-              </a:defRPr>
-            </a:pPr>
-            <a:r>
-              <a:rPr dirty="0"/>
-              <a:t>and open in the user's default browser.</a:t>
-            </a:r>
-          </a:p>
-          <a:p>
-            <a:pPr>
-              <a:lnSpc>
-                <a:spcPts val="1800"/>
-              </a:lnSpc>
-              <a:defRPr sz="1300">
-                <a:solidFill>
-                  <a:srgbClr val="374151"/>
-                </a:solidFill>
-                <a:latin typeface="Courier New"/>
-              </a:defRPr>
-            </a:pPr>
-            <a:r>
-              <a:rPr dirty="0"/>
-              <a:t>Thoroughly fact check everything you claim in the report.</a:t>
-            </a:r>
-          </a:p>
-        </p:txBody>
-      </p:sp>
-    </p:spTree>
-  </p:cSld>
-  <p:clrMapOvr>
-    <a:masterClrMapping/>
-  </p:clrMapOvr>
-</p:sld>
-</file>
-
-<file path=ppt/slides/slide47.xml><?xml version="1.0" encoding="utf-8"?>
 <p:sld xmlns:a="http://schemas.openxmlformats.org/drawingml/2006/main" xmlns:r="http://schemas.openxmlformats.org/officeDocument/2006/relationships" xmlns:p="http://schemas.openxmlformats.org/presentationml/2006/main">
   <p:cSld>
     <p:spTree>

</xml_diff>

<commit_message>
docs: update KISS Sorcar lecture slides with latest content
User prompt:
can you update the slides at PWD/papers/kisssorcar/KISS_Sorcar_Lecture.pptx based on the latest PWD/papers/kisssorcar/kiss_sorcar.tex ?
</commit_message>
<xml_diff>
--- a/papers/kisssorcar/KISS_Sorcar_Lecture.pptx
+++ b/papers/kisssorcar/KISS_Sorcar_Lecture.pptx
@@ -10481,7 +10481,7 @@
               </a:defRPr>
             </a:pPr>
             <a:r>
-              <a:t>Pre-flight Checks</a:t>
+              <a:t>Pre-flight Checks + Mandatory First Actions</a:t>
             </a:r>
           </a:p>
         </p:txBody>
@@ -11034,7 +11034,7 @@
               </a:defRPr>
             </a:pPr>
             <a:r>
-              <a:t>Web Research Protocol</a:t>
+              <a:t>Web Research + Real-Time Data</a:t>
             </a:r>
           </a:p>
         </p:txBody>
@@ -11805,7 +11805,24 @@
             </a:pPr>
             <a:r>
               <a:rPr dirty="0"/>
-              <a:t>&lt;visibility_constraint&gt;  User sees only finish(summary=...).&lt;/visibility_constraint&gt;</a:t>
+              <a:t>&lt;visibility_constraint&gt;  User sees only finish(summary=...).</a:t>
+            </a:r>
+          </a:p>
+          <a:p>
+            <a:pPr>
+              <a:lnSpc>
+                <a:spcPts val="1800"/>
+              </a:lnSpc>
+              <a:defRPr sz="1300">
+                <a:solidFill>
+                  <a:srgbClr val="374151"/>
+                </a:solidFill>
+                <a:latin typeface="Courier New"/>
+              </a:defRPr>
+            </a:pPr>
+            <a:r>
+              <a:rPr dirty="0"/>
+              <a:t>Bad: "Greeted user, awaiting task."   Good: "Hi! I’m KISS Sorcar, ready to help."&lt;/visibility_constraint&gt;</a:t>
             </a:r>
           </a:p>
         </p:txBody>
@@ -12607,7 +12624,7 @@
               </a:defRPr>
             </a:pPr>
             <a:r>
-              <a:t>• Bash timeout: 300s default, retry higher, background for &gt;10min</a:t>
+              <a:t>• Bash timeout: 120s default, retry higher, background for &gt;10min</a:t>
             </a:r>
           </a:p>
         </p:txBody>
@@ -12887,7 +12904,7 @@
               </a:defRPr>
             </a:pPr>
             <a:r>
-              <a:t>• Create temp files in PWD/tmp</a:t>
+              <a:t>• PWD/tmp/ for ALL temp files (CRITICAL); clean up before finish</a:t>
             </a:r>
           </a:p>
         </p:txBody>
@@ -12922,7 +12939,7 @@
               </a:defRPr>
             </a:pPr>
             <a:r>
-              <a:t>→ Centralizes artifacts, prevents polluting the project tree</a:t>
+              <a:t>→ Never directly in PWD/; delete only files you created</a:t>
             </a:r>
           </a:p>
         </p:txBody>
@@ -12992,7 +13009,7 @@
               </a:defRPr>
             </a:pPr>
             <a:r>
-              <a:t>→ Disambiguates web access vs curl / Python / shell</a:t>
+              <a:t>→ Disambiguates web access; ambiguous tasks trigger web research</a:t>
             </a:r>
           </a:p>
         </p:txBody>
@@ -13246,7 +13263,7 @@
               </a:defRPr>
             </a:pPr>
             <a:r>
-              <a:t>✓  Read every file you will modify before changing it</a:t>
+              <a:t>✓  Read before modify — use Read() tool, never Bash cat</a:t>
             </a:r>
           </a:p>
         </p:txBody>
@@ -13284,7 +13301,7 @@
               </a:defRPr>
             </a:pPr>
             <a:r>
-              <a:t>Most common bug source: editing based on stale mental model.</a:t>
+              <a:t>Most common bug: editing based on stale state.</a:t>
             </a:r>
           </a:p>
           <a:p>
@@ -13299,7 +13316,7 @@
               </a:defRPr>
             </a:pPr>
             <a:r>
-              <a:t>Fresh read ensures operating on current state.</a:t>
+              <a:t>Mandatory first reads: SORCAR.md, then USER_DEFS.md.</a:t>
             </a:r>
           </a:p>
         </p:txBody>
@@ -17255,7 +17272,7 @@
               </a:defRPr>
             </a:pPr>
             <a:r>
-              <a:t>Read USER_PREFS.md</a:t>
+              <a:t>Mandatory first reads:</a:t>
             </a:r>
           </a:p>
           <a:p>
@@ -17267,7 +17284,7 @@
               </a:defRPr>
             </a:pPr>
             <a:r>
-              <a:t>at task start</a:t>
+              <a:t>SORCAR.md, USER_DEFS.md</a:t>
             </a:r>
           </a:p>
         </p:txBody>
@@ -17387,7 +17404,7 @@
               </a:defRPr>
             </a:pPr>
             <a:r>
-              <a:t>Update USER_PREFS.md</a:t>
+              <a:t>Before finish: update</a:t>
             </a:r>
           </a:p>
           <a:p>
@@ -17399,7 +17416,7 @@
               </a:defRPr>
             </a:pPr>
             <a:r>
-              <a:t>with new invariants</a:t>
+              <a:t>USER_PREFS.md</a:t>
             </a:r>
           </a:p>
         </p:txBody>
@@ -17605,7 +17622,7 @@
               </a:defRPr>
             </a:pPr>
             <a:r>
-              <a:t>• Progressively more effective without manual configuration by the developer</a:t>
+              <a:t>• Keep USER_PREFS.md small — it loads into every future task’s context</a:t>
             </a:r>
           </a:p>
         </p:txBody>
@@ -18053,7 +18070,7 @@
               </a:defRPr>
             </a:pPr>
             <a:r>
-              <a:t>Run lint, typecheck, tests</a:t>
+              <a:t>Run `uv run check --full` (mandatory for code)</a:t>
             </a:r>
           </a:p>
         </p:txBody>
@@ -18088,7 +18105,7 @@
               </a:defRPr>
             </a:pPr>
             <a:r>
-              <a:t>Objective automated verification replaces subjective assessment</a:t>
+              <a:t>Required for any .py/.ts/.js/.css edit — verifiable mandate, not a soft guideline</a:t>
             </a:r>
           </a:p>
         </p:txBody>
@@ -18301,7 +18318,7 @@
               </a:defRPr>
             </a:pPr>
             <a:r>
-              <a:t>If any check fails → keep working</a:t>
+              <a:t>Clean up tmp/ files you created</a:t>
             </a:r>
           </a:p>
         </p:txBody>
@@ -18336,7 +18353,7 @@
               </a:defRPr>
             </a:pPr>
             <a:r>
-              <a:t>No finishing with known failures, no rationalizing failures as minor</a:t>
+              <a:t>Delete only files you created in PWD/tmp/; preserve everything else</a:t>
             </a:r>
           </a:p>
         </p:txBody>
@@ -18425,7 +18442,7 @@
               </a:defRPr>
             </a:pPr>
             <a:r>
-              <a:t>3 retries without progress → rethink</a:t>
+              <a:t>Don’t finish with failures; rethink after 3 retries</a:t>
             </a:r>
           </a:p>
         </p:txBody>
@@ -18803,7 +18820,7 @@
               </a:defRPr>
             </a:pPr>
             <a:r>
-              <a:t>• Visit AT LEAST 30 websites</a:t>
+              <a:t>• Visit AT LEAST 10 websites (HARD requirement)</a:t>
             </a:r>
           </a:p>
         </p:txBody>
@@ -18838,7 +18855,7 @@
               </a:defRPr>
             </a:pPr>
             <a:r>
-              <a:t>• Collect info into PWD/tmp/information-{id}.md</a:t>
+              <a:t>• Use go_to_url() only — NOT curl/wget (loophole closed)</a:t>
             </a:r>
           </a:p>
         </p:txBody>
@@ -18873,7 +18890,7 @@
               </a:defRPr>
             </a:pPr>
             <a:r>
-              <a:t>• Then synthesize — think deeply, then act</a:t>
+              <a:t>• Collect into PWD/tmp/information-{id}.md (your proof of work)</a:t>
             </a:r>
           </a:p>
         </p:txBody>
@@ -18908,7 +18925,7 @@
               </a:defRPr>
             </a:pPr>
             <a:r>
-              <a:t>• Counteracts anchoring bias on first few results</a:t>
+              <a:t>• Real-time data: look it up — never answer from training memory</a:t>
             </a:r>
           </a:p>
         </p:txBody>
@@ -18943,7 +18960,7 @@
               </a:defRPr>
             </a:pPr>
             <a:r>
-              <a:t>• Skip for pure code edits / bug fixes with sufficient local context</a:t>
+              <a:t>• Don’t fabricate source counts; skip for code edits with context</a:t>
             </a:r>
           </a:p>
         </p:txBody>

</xml_diff>